<commit_message>
Correct CEI overview scientific wording
</commit_message>
<xml_diff>
--- a/docs/presentations/cei-overview/cei-overview.pptx
+++ b/docs/presentations/cei-overview/cei-overview.pptx
@@ -644,7 +644,7 @@
           <a:lstStyle/>
           <a:p>
             <a:r>
-              <a:t>Source: docs/cei-v3-delivery-2026-10-01.md and docs/cei-v3-evidence-2026-10-01.json (aggregate only). Cohort: max6 (patients with more than 6 total visits excluded), train-derived Top-10 classes; 10,000 train, 5,000 dev (selection), 5,000 screen visits, 4,254 validation. Seeds 1234/2025/7, patient-disjoint; key weighted_macro_f1 (patient-equal). Held-out test untouched. Screen seed means: CEI v3 C 0.6418, v2 A 0.6420, ProtGNN 0.6371, XGBoost 0.6371. No screen contrast passes the preregistered rule; v3 benefit over v2 not demonstrated. Validation second-look (opened after the inconclusive screen, no multiplicity correction, 3 seeds): C 0.6395 vs ProtGNN 0.6303, delta 0.0092 (95% CI 0.0024-0.0153); not a broad winner claim, and no XGBoost victory is claimed. A non-significant interval is not evidence of equivalence. GraphXAI: 500 screen visits / 498 subjects, 3 seeds; Grad and IG favour CEI on fidelity-minus and sparsity, not uniformly on fidelity-plus; native ProtGNN explanations unavailable. Faithfulness to the model, not clinical validity. Arm C absence share is about 1.7-1.8% of visits (row mean); arm B without absence is above C on screen, so no benefit of absence evidence is shown.</a:t>
+              <a:t>Source: docs/cei-v3-delivery-2026-10-01.md and docs/cei-v3-evidence-2026-10-01.json (aggregate only). Cohort: max6 (patients with more than 6 total visits excluded), train-derived Top-10 classes; 10,000 train, 5,000 dev (selection), 5,000 screen visits, 4,254 validation. Seeds 1234/2025/7, patient-disjoint; key weighted_macro_f1 (patient-equal). Held-out test untouched. Screen seed means: CEI v3 C 0.6418, v2 A 0.6420, ProtGNN 0.6371, XGBoost 0.6371. No screen contrast passes the preregistered rule; v3 benefit over v2 not demonstrated. Validation second-look (opened after the inconclusive screen, no multiplicity correction, 3 seeds): C 0.6395 vs ProtGNN 0.6303, delta 0.0092 (95% CI 0.0024-0.0153); not a broad winner claim, and no XGBoost victory is claimed. A non-significant interval is not evidence of equivalence. GraphXAI: 500 screen visits / 498 subjects, 3 seeds; comparison using Grad and IG: CEI outperforms ProtGNN on fidelity-minus and sparsity, not uniformly on fidelity-plus; native ProtGNN attribution unavailable in this implementation. Faithfulness to the model, not clinical validity. Arm C absence evidence share is about 1.7-1.8%, averaged over visits; arm B without absence is above C on screen, so no benefit of absence evidence is shown.</a:t>
             </a:r>
           </a:p>
         </p:txBody>
@@ -7180,7 +7180,7 @@
                 </a:solidFill>
                 <a:latin typeface="Arial"/>
               </a:rPr>
-              <a:t>Explanations are model-faithful, not clinical proof. </a:t>
+              <a:t>Explanation evidence is mixed. </a:t>
             </a:r>
             <a:r>
               <a:rPr sz="1800" b="0">
@@ -7189,7 +7189,7 @@
                 </a:solidFill>
                 <a:latin typeface="Arial"/>
               </a:rPr>
-              <a:t>Against Grad and IG on 500 screen visits, CEI is favoured on fidelity-minus and sparsity, not uniformly on fidelity-plus; ProtGNN has no native explanation to compare.</a:t>
+              <a:t>Using Grad and IG on 500 screen visits, CEI outperforms ProtGNN on fidelity-minus and sparsity, not uniformly on fidelity-plus. Native ProtGNN attribution was unavailable in this implementation.</a:t>
             </a:r>
           </a:p>
           <a:p>
@@ -7205,7 +7205,7 @@
                 </a:solidFill>
                 <a:latin typeface="Arial"/>
               </a:rPr>
-              <a:t>Accuracy is on par, not superior. </a:t>
+              <a:t>Superiority is not established. </a:t>
             </a:r>
             <a:r>
               <a:rPr sz="1800" b="0">
@@ -7214,7 +7214,7 @@
                 </a:solidFill>
                 <a:latin typeface="Arial"/>
               </a:rPr>
-              <a:t>Differences are within about 0.005; no winner claim.</a:t>
+              <a:t>The screen is inconclusive; this does not prove equivalence.</a:t>
             </a:r>
           </a:p>
         </p:txBody>

</xml_diff>

<commit_message>
docs: add numeric GraphXAI metrics to CEI deck
</commit_message>
<xml_diff>
--- a/docs/presentations/cei-overview/cei-overview.pptx
+++ b/docs/presentations/cei-overview/cei-overview.pptx
@@ -644,7 +644,62 @@
           <a:lstStyle/>
           <a:p>
             <a:r>
-              <a:t>Source: docs/cei-v3-delivery-2026-10-01.md and docs/cei-v3-evidence-2026-10-01.json (aggregate only). Cohort: max6 (patients with more than 6 total visits excluded), train-derived Top-10 classes; 10,000 train, 5,000 dev (selection), 5,000 screen visits, 4,254 validation. Seeds 1234/2025/7, patient-disjoint; key weighted_macro_f1 (patient-equal). Held-out test untouched. Screen seed means: CEI v3 C 0.6418, v2 A 0.6420, ProtGNN 0.6371, XGBoost 0.6371. No screen contrast passes the preregistered rule; v3 benefit over v2 not demonstrated. Validation second-look (opened after the inconclusive screen, no multiplicity correction, 3 seeds): C 0.6395 vs ProtGNN 0.6303, delta 0.0092 (95% CI 0.0024-0.0153); not a broad winner claim, and no XGBoost victory is claimed. A non-significant interval is not evidence of equivalence. GraphXAI: 500 screen visits / 498 subjects, 3 seeds; comparison using Grad and IG: CEI outperforms ProtGNN on fidelity-minus and sparsity, not uniformly on fidelity-plus; native ProtGNN attribution unavailable in this implementation. Faithfulness to the model, not clinical validity. Arm C absence evidence share is about 1.7-1.8%, averaged over visits; arm B without absence is above C on screen, so no benefit of absence evidence is shown.</a:t>
+              <a:t>Source keys: docs/cei-v3-evidence-2026-10-01.json graphxai.seed_means and graphxai.C_minus_P. Absolute seed means C_K4 / P, rounded to 3 decimals:</a:t>
+            </a:r>
+          </a:p>
+          <a:p>
+            <a:r>
+              <a:t>Native: fidelity_minus=0.105/N/A; fidelity_plus=0.554/N/A; sparsity=0.700/N/A</a:t>
+            </a:r>
+          </a:p>
+          <a:p>
+            <a:r>
+              <a:t>GradExplainer: fidelity_minus=0.144/0.571; fidelity_plus=0.509/0.510; sparsity=0.513/0.388</a:t>
+            </a:r>
+          </a:p>
+          <a:p>
+            <a:r>
+              <a:t>IntegratedGradExplainer: fidelity_minus=0.100/0.570; fidelity_plus=0.538/0.535; sparsity=0.521/0.289</a:t>
+            </a:r>
+          </a:p>
+          <a:p>
+            <a:r>
+              <a:t>GNNExplainer: fidelity_minus=0.398/0.576; fidelity_plus=0.216/0.381; sparsity=0.269/0.270</a:t>
+            </a:r>
+          </a:p>
+          <a:p>
+            <a:r>
+              <a:t>Random: fidelity_minus=0.484/0.578; fidelity_plus=0.107/0.309; sparsity=0.285/0.285</a:t>
+            </a:r>
+          </a:p>
+          <a:p>
+            <a:r>
+              <a:t>Paired differences are C_minus_P, not absolute scores; 95% paired subject-cluster bootstrap CIs, conditional on three checkpoints:</a:t>
+            </a:r>
+          </a:p>
+          <a:p>
+            <a:r>
+              <a:t>GradExplainer: fidelity_minus: delta C_minus_P=-0.427162, 95% CI=[-0.44985684363473355, -0.40430027914714267]; fidelity_plus: delta C_minus_P=-0.000864, 95% CI=[-0.018268945488595492, 0.01593477348389595]; sparsity: delta C_minus_P=0.125484, 95% CI=[0.11304490685296074, 0.13725250397127586]</a:t>
+            </a:r>
+          </a:p>
+          <a:p>
+            <a:r>
+              <a:t>IntegratedGradExplainer: fidelity_minus: delta C_minus_P=-0.470263, 95% CI=[-0.4935411711680781, -0.44786387276011425]; fidelity_plus: delta C_minus_P=0.003283, 95% CI=[-0.01288460690326586, 0.018862188015107674]; sparsity: delta C_minus_P=0.231820, 95% CI=[0.2217338810107095, 0.2406996905288059]</a:t>
+            </a:r>
+          </a:p>
+          <a:p>
+            <a:r>
+              <a:t>GNNExplainer: fidelity_minus: delta C_minus_P=-0.177784, 95% CI=[-0.20115243419378384, -0.15470507840750994]; fidelity_plus: delta C_minus_P=-0.165147, 95% CI=[-0.18303717712992937, -0.14623125127908276]; sparsity: delta C_minus_P=-0.000995, 95% CI=[-0.002651219104876419, 0.0006569820379281496]</a:t>
+            </a:r>
+          </a:p>
+          <a:p>
+            <a:r>
+              <a:t>Random: fidelity_minus: delta C_minus_P=-0.094264, 95% CI=[-0.11447657641503317, -0.07460849767977928]; fidelity_plus: delta C_minus_P=-0.201560, 95% CI=[-0.2187959747065453, -0.18241111693875542]; sparsity: delta C_minus_P=0.000000, 95% CI=[0.0, 0.0]</a:t>
+            </a:r>
+          </a:p>
+          <a:p>
+            <a:r>
+              <a:t>Fidelity-minus: prediction change after removing important nodes (keeping important nodes is thereby tested); fidelity-plus: prediction change when important nodes are retained after other nodes are removed. Sparsity is excluded-node fraction at 90% importance mass. Cohort: 500 screen visits / 498 subjects / 3 seeds. Native ProtGNN unavailable. These are model-faithfulness metrics, not clinical validity. No macro-F1 superiority or equivalence claim.</a:t>
             </a:r>
           </a:p>
         </p:txBody>
@@ -6660,7 +6715,7 @@
                 </a:solidFill>
                 <a:latin typeface="Arial"/>
               </a:rPr>
-              <a:t>What the evidence supports</a:t>
+              <a:t>Accuracy is close; explanation metrics differ</a:t>
             </a:r>
           </a:p>
         </p:txBody>
@@ -6717,8 +6772,8 @@
         </p:nvSpPr>
         <p:spPr>
           <a:xfrm>
-            <a:off x="548640" y="1280160"/>
-            <a:ext cx="5760720" cy="365760"/>
+            <a:off x="548640" y="1261872"/>
+            <a:ext cx="3337560" cy="384048"/>
           </a:xfrm>
           <a:prstGeom prst="rect">
             <a:avLst/>
@@ -6733,13 +6788,13 @@
           <a:p>
             <a:pPr algn="l"/>
             <a:r>
-              <a:rPr sz="1600" b="1">
+              <a:rPr sz="1700" b="1">
                 <a:solidFill>
-                  <a:srgbClr val="555555"/>
+                  <a:srgbClr val="16324F"/>
                 </a:solidFill>
                 <a:latin typeface="Arial"/>
               </a:rPr>
-              <a:t>Primary screen, macro-F1 (3-seed mean)</a:t>
+              <a:t>Primary screen: macro-F1</a:t>
             </a:r>
           </a:p>
         </p:txBody>
@@ -6753,8 +6808,8 @@
           <p:nvPr/>
         </p:nvGraphicFramePr>
         <p:xfrm>
-          <a:off x="548640" y="1783080"/>
-          <a:ext cx="5760720" cy="2651760"/>
+          <a:off x="548640" y="1691640"/>
+          <a:ext cx="3337560" cy="2057400"/>
         </p:xfrm>
         <a:graphic>
           <a:graphicData uri="http://schemas.openxmlformats.org/drawingml/2006/table">
@@ -6763,10 +6818,10 @@
                 <a:tableStyleId>{5C22544A-7EE6-4342-B048-85BDC9FD1C3A}</a:tableStyleId>
               </a:tblPr>
               <a:tblGrid>
-                <a:gridCol w="3931920"/>
-                <a:gridCol w="1828800"/>
+                <a:gridCol w="2240280"/>
+                <a:gridCol w="1097280"/>
               </a:tblGrid>
-              <a:tr h="530352">
+              <a:tr h="411480">
                 <a:tc>
                   <a:txBody>
                     <a:bodyPr/>
@@ -6774,7 +6829,7 @@
                     <a:p>
                       <a:pPr algn="l"/>
                       <a:r>
-                        <a:rPr sz="2000" b="1">
+                        <a:rPr sz="1600" b="1">
                           <a:solidFill>
                             <a:srgbClr val="FFFFFF"/>
                           </a:solidFill>
@@ -6797,7 +6852,7 @@
                     <a:p>
                       <a:pPr algn="r"/>
                       <a:r>
-                        <a:rPr sz="2000" b="1">
+                        <a:rPr sz="1600" b="1">
                           <a:solidFill>
                             <a:srgbClr val="FFFFFF"/>
                           </a:solidFill>
@@ -6814,7 +6869,7 @@
                   </a:tcPr>
                 </a:tc>
               </a:tr>
-              <a:tr h="530352">
+              <a:tr h="411480">
                 <a:tc>
                   <a:txBody>
                     <a:bodyPr/>
@@ -6822,13 +6877,13 @@
                     <a:p>
                       <a:pPr algn="l"/>
                       <a:r>
-                        <a:rPr sz="2000" b="1">
+                        <a:rPr sz="1600" b="1">
                           <a:solidFill>
                             <a:srgbClr val="111111"/>
                           </a:solidFill>
                           <a:latin typeface="Arial"/>
                         </a:rPr>
-                        <a:t>CEI-GNN v3 (arm C)</a:t>
+                        <a:t>CEI-GNN v3</a:t>
                       </a:r>
                     </a:p>
                   </a:txBody>
@@ -6845,13 +6900,13 @@
                     <a:p>
                       <a:pPr algn="r"/>
                       <a:r>
-                        <a:rPr sz="2000" b="1">
+                        <a:rPr sz="1600" b="1">
                           <a:solidFill>
                             <a:srgbClr val="111111"/>
                           </a:solidFill>
                           <a:latin typeface="Arial"/>
                         </a:rPr>
-                        <a:t>0.6418</a:t>
+                        <a:t>0.642</a:t>
                       </a:r>
                     </a:p>
                   </a:txBody>
@@ -6862,7 +6917,7 @@
                   </a:tcPr>
                 </a:tc>
               </a:tr>
-              <a:tr h="530352">
+              <a:tr h="411480">
                 <a:tc>
                   <a:txBody>
                     <a:bodyPr/>
@@ -6870,13 +6925,13 @@
                     <a:p>
                       <a:pPr algn="l"/>
                       <a:r>
-                        <a:rPr sz="2000" b="0">
+                        <a:rPr sz="1600" b="0">
                           <a:solidFill>
                             <a:srgbClr val="111111"/>
                           </a:solidFill>
                           <a:latin typeface="Arial"/>
                         </a:rPr>
-                        <a:t>CEI-GNN v2 (arm A)</a:t>
+                        <a:t>CEI-GNN v2</a:t>
                       </a:r>
                     </a:p>
                   </a:txBody>
@@ -6893,13 +6948,13 @@
                     <a:p>
                       <a:pPr algn="r"/>
                       <a:r>
-                        <a:rPr sz="2000" b="0">
+                        <a:rPr sz="1600" b="0">
                           <a:solidFill>
                             <a:srgbClr val="111111"/>
                           </a:solidFill>
                           <a:latin typeface="Arial"/>
                         </a:rPr>
-                        <a:t>0.6420</a:t>
+                        <a:t>0.642</a:t>
                       </a:r>
                     </a:p>
                   </a:txBody>
@@ -6910,7 +6965,7 @@
                   </a:tcPr>
                 </a:tc>
               </a:tr>
-              <a:tr h="530352">
+              <a:tr h="411480">
                 <a:tc>
                   <a:txBody>
                     <a:bodyPr/>
@@ -6918,7 +6973,7 @@
                     <a:p>
                       <a:pPr algn="l"/>
                       <a:r>
-                        <a:rPr sz="2000" b="0">
+                        <a:rPr sz="1600" b="0">
                           <a:solidFill>
                             <a:srgbClr val="111111"/>
                           </a:solidFill>
@@ -6941,13 +6996,13 @@
                     <a:p>
                       <a:pPr algn="r"/>
                       <a:r>
-                        <a:rPr sz="2000" b="0">
+                        <a:rPr sz="1600" b="0">
                           <a:solidFill>
                             <a:srgbClr val="111111"/>
                           </a:solidFill>
                           <a:latin typeface="Arial"/>
                         </a:rPr>
-                        <a:t>0.6371</a:t>
+                        <a:t>0.637</a:t>
                       </a:r>
                     </a:p>
                   </a:txBody>
@@ -6958,7 +7013,7 @@
                   </a:tcPr>
                 </a:tc>
               </a:tr>
-              <a:tr h="530352">
+              <a:tr h="411480">
                 <a:tc>
                   <a:txBody>
                     <a:bodyPr/>
@@ -6966,7 +7021,7 @@
                     <a:p>
                       <a:pPr algn="l"/>
                       <a:r>
-                        <a:rPr sz="2000" b="0">
+                        <a:rPr sz="1600" b="0">
                           <a:solidFill>
                             <a:srgbClr val="111111"/>
                           </a:solidFill>
@@ -6989,13 +7044,13 @@
                     <a:p>
                       <a:pPr algn="r"/>
                       <a:r>
-                        <a:rPr sz="2000" b="0">
+                        <a:rPr sz="1600" b="0">
                           <a:solidFill>
                             <a:srgbClr val="111111"/>
                           </a:solidFill>
                           <a:latin typeface="Arial"/>
                         </a:rPr>
-                        <a:t>0.6371</a:t>
+                        <a:t>0.637</a:t>
                       </a:r>
                     </a:p>
                   </a:txBody>
@@ -7012,62 +7067,14 @@
       </p:graphicFrame>
       <p:sp>
         <p:nvSpPr>
-          <p:cNvPr id="6" name="Rounded Rectangle 5"/>
-          <p:cNvSpPr/>
-          <p:nvPr/>
-        </p:nvSpPr>
-        <p:spPr>
-          <a:xfrm>
-            <a:off x="548640" y="4617720"/>
-            <a:ext cx="5760720" cy="1143000"/>
-          </a:xfrm>
-          <a:prstGeom prst="roundRect">
-            <a:avLst>
-              <a:gd name="adj" fmla="val 12000"/>
-            </a:avLst>
-          </a:prstGeom>
-          <a:solidFill>
-            <a:srgbClr val="FFFFFF"/>
-          </a:solidFill>
-          <a:ln w="28575">
-            <a:solidFill>
-              <a:srgbClr val="0B7A75"/>
-            </a:solidFill>
-          </a:ln>
-          <a:effectLst/>
-        </p:spPr>
-        <p:style>
-          <a:lnRef idx="1">
-            <a:schemeClr val="accent1"/>
-          </a:lnRef>
-          <a:fillRef idx="3">
-            <a:schemeClr val="accent1"/>
-          </a:fillRef>
-          <a:effectRef idx="2">
-            <a:schemeClr val="accent1"/>
-          </a:effectRef>
-          <a:fontRef idx="minor">
-            <a:schemeClr val="lt1"/>
-          </a:fontRef>
-        </p:style>
-        <p:txBody>
-          <a:bodyPr rtlCol="0" anchor="ctr" wrap="square" lIns="45720" rIns="45720" tIns="18288" bIns="18288"/>
-          <a:lstStyle/>
-          <a:p>
-            <a:pPr algn="ctr"/>
-          </a:p>
-        </p:txBody>
-      </p:sp>
-      <p:sp>
-        <p:nvSpPr>
-          <p:cNvPr id="7" name="TextBox 6"/>
+          <p:cNvPr id="6" name="TextBox 5"/>
           <p:cNvSpPr txBox="1"/>
           <p:nvPr/>
         </p:nvSpPr>
         <p:spPr>
           <a:xfrm>
-            <a:off x="685800" y="4663440"/>
-            <a:ext cx="5486400" cy="1051560"/>
+            <a:off x="566928" y="3822191"/>
+            <a:ext cx="3337560" cy="603504"/>
           </a:xfrm>
           <a:prstGeom prst="rect">
             <a:avLst/>
@@ -7075,20 +7082,55 @@
           <a:noFill/>
         </p:spPr>
         <p:txBody>
-          <a:bodyPr wrap="square" anchor="ctr" lIns="36576" rIns="36576" tIns="18288" bIns="18288">
+          <a:bodyPr wrap="square" anchor="t" lIns="36576" rIns="36576" tIns="18288" bIns="18288">
             <a:spAutoFit/>
           </a:bodyPr>
           <a:lstStyle/>
           <a:p>
             <a:pPr algn="l"/>
             <a:r>
-              <a:rPr sz="2400" b="1">
+              <a:rPr sz="1400" b="0">
+                <a:solidFill>
+                  <a:srgbClr val="555555"/>
+                </a:solidFill>
+                <a:latin typeface="Arial"/>
+              </a:rPr>
+              <a:t>Patient-equal macro-F1; 5,000 screen visits / 3 seeds.</a:t>
+            </a:r>
+          </a:p>
+        </p:txBody>
+      </p:sp>
+      <p:sp>
+        <p:nvSpPr>
+          <p:cNvPr id="7" name="TextBox 6"/>
+          <p:cNvSpPr txBox="1"/>
+          <p:nvPr/>
+        </p:nvSpPr>
+        <p:spPr>
+          <a:xfrm>
+            <a:off x="566928" y="4572000"/>
+            <a:ext cx="3291840" cy="1005840"/>
+          </a:xfrm>
+          <a:prstGeom prst="rect">
+            <a:avLst/>
+          </a:prstGeom>
+          <a:noFill/>
+        </p:spPr>
+        <p:txBody>
+          <a:bodyPr wrap="square" anchor="t" lIns="36576" rIns="36576" tIns="18288" bIns="18288">
+            <a:spAutoFit/>
+          </a:bodyPr>
+          <a:lstStyle/>
+          <a:p>
+            <a:pPr algn="l"/>
+            <a:r>
+              <a:rPr sz="1700" b="1">
                 <a:solidFill>
                   <a:srgbClr val="0B7A75"/>
                 </a:solidFill>
                 <a:latin typeface="Arial"/>
               </a:rPr>
-              <a:t>No decisive screen gain yet</a:t>
+              <a:t>No decisive accuracy gain on the primary screen.</a:t>
             </a:r>
           </a:p>
           <a:p>
@@ -7104,7 +7146,7 @@
                 </a:solidFill>
                 <a:latin typeface="Arial"/>
               </a:rPr>
-              <a:t>No contrast passes the preregistered rule; v3 over v2: −0.0002, 95% CI [−0.0047, +0.0042].</a:t>
+              <a:t>No superiority or equivalence claim.</a:t>
             </a:r>
           </a:p>
         </p:txBody>
@@ -7117,8 +7159,8 @@
         </p:nvSpPr>
         <p:spPr>
           <a:xfrm>
-            <a:off x="6766560" y="1280160"/>
-            <a:ext cx="4937760" cy="4480560"/>
+            <a:off x="4069080" y="1261872"/>
+            <a:ext cx="7543800" cy="365760"/>
           </a:xfrm>
           <a:prstGeom prst="rect">
             <a:avLst/>
@@ -7133,13 +7175,819 @@
           <a:p>
             <a:pPr algn="l"/>
             <a:r>
-              <a:rPr sz="2000" b="1">
+              <a:rPr sz="1700" b="1">
                 <a:solidFill>
                   <a:srgbClr val="16324F"/>
                 </a:solidFill>
                 <a:latin typeface="Arial"/>
               </a:rPr>
-              <a:t>What we can say</a:t>
+              <a:t>Model-faithfulness metrics (absolute seed means)</a:t>
+            </a:r>
+          </a:p>
+        </p:txBody>
+      </p:sp>
+      <p:graphicFrame>
+        <p:nvGraphicFramePr>
+          <p:cNvPr id="9" name="Table 8"/>
+          <p:cNvGraphicFramePr>
+            <a:graphicFrameLocks noGrp="1"/>
+          </p:cNvGraphicFramePr>
+          <p:nvPr/>
+        </p:nvGraphicFramePr>
+        <p:xfrm>
+          <a:off x="4069080" y="1691640"/>
+          <a:ext cx="7543800" cy="2788920"/>
+        </p:xfrm>
+        <a:graphic>
+          <a:graphicData uri="http://schemas.openxmlformats.org/drawingml/2006/table">
+            <a:tbl>
+              <a:tblPr firstRow="1" bandRow="1">
+                <a:tableStyleId>{5C22544A-7EE6-4342-B048-85BDC9FD1C3A}</a:tableStyleId>
+              </a:tblPr>
+              <a:tblGrid>
+                <a:gridCol w="1417320"/>
+                <a:gridCol w="1965960"/>
+                <a:gridCol w="2148840"/>
+                <a:gridCol w="2011680"/>
+              </a:tblGrid>
+              <a:tr h="464820">
+                <a:tc>
+                  <a:txBody>
+                    <a:bodyPr/>
+                    <a:lstStyle/>
+                    <a:p>
+                      <a:pPr algn="l">
+                        <a:spcAft>
+                          <a:spcPts val="0"/>
+                        </a:spcAft>
+                      </a:pPr>
+                      <a:r>
+                        <a:rPr sz="1400" b="1">
+                          <a:solidFill>
+                            <a:srgbClr val="FFFFFF"/>
+                          </a:solidFill>
+                          <a:latin typeface="Arial"/>
+                        </a:rPr>
+                        <a:t>Explainer</a:t>
+                      </a:r>
+                    </a:p>
+                  </a:txBody>
+                  <a:tcPr anchor="ctr" marL="41148" marR="41148" marT="18288" marB="18288">
+                    <a:solidFill>
+                      <a:srgbClr val="16324F"/>
+                    </a:solidFill>
+                  </a:tcPr>
+                </a:tc>
+                <a:tc>
+                  <a:txBody>
+                    <a:bodyPr/>
+                    <a:lstStyle/>
+                    <a:p>
+                      <a:pPr algn="l">
+                        <a:spcAft>
+                          <a:spcPts val="0"/>
+                        </a:spcAft>
+                      </a:pPr>
+                      <a:r>
+                        <a:rPr sz="1400" b="1">
+                          <a:solidFill>
+                            <a:srgbClr val="FFFFFF"/>
+                          </a:solidFill>
+                          <a:latin typeface="Arial"/>
+                        </a:rPr>
+                        <a:t>Fidelity-</a:t>
+                      </a:r>
+                    </a:p>
+                    <a:p>
+                      <a:pPr algn="l">
+                        <a:spcAft>
+                          <a:spcPts val="0"/>
+                        </a:spcAft>
+                      </a:pPr>
+                      <a:r>
+                        <a:rPr sz="1400" b="1">
+                          <a:solidFill>
+                            <a:srgbClr val="FFFFFF"/>
+                          </a:solidFill>
+                          <a:latin typeface="Arial"/>
+                        </a:rPr>
+                        <a:t>(lower better)</a:t>
+                      </a:r>
+                    </a:p>
+                  </a:txBody>
+                  <a:tcPr anchor="ctr" marL="41148" marR="41148" marT="18288" marB="18288">
+                    <a:solidFill>
+                      <a:srgbClr val="16324F"/>
+                    </a:solidFill>
+                  </a:tcPr>
+                </a:tc>
+                <a:tc>
+                  <a:txBody>
+                    <a:bodyPr/>
+                    <a:lstStyle/>
+                    <a:p>
+                      <a:pPr algn="l">
+                        <a:spcAft>
+                          <a:spcPts val="0"/>
+                        </a:spcAft>
+                      </a:pPr>
+                      <a:r>
+                        <a:rPr sz="1400" b="1">
+                          <a:solidFill>
+                            <a:srgbClr val="FFFFFF"/>
+                          </a:solidFill>
+                          <a:latin typeface="Arial"/>
+                        </a:rPr>
+                        <a:t>Fidelity+</a:t>
+                      </a:r>
+                    </a:p>
+                    <a:p>
+                      <a:pPr algn="l">
+                        <a:spcAft>
+                          <a:spcPts val="0"/>
+                        </a:spcAft>
+                      </a:pPr>
+                      <a:r>
+                        <a:rPr sz="1400" b="1">
+                          <a:solidFill>
+                            <a:srgbClr val="FFFFFF"/>
+                          </a:solidFill>
+                          <a:latin typeface="Arial"/>
+                        </a:rPr>
+                        <a:t>(higher better)</a:t>
+                      </a:r>
+                    </a:p>
+                  </a:txBody>
+                  <a:tcPr anchor="ctr" marL="41148" marR="41148" marT="18288" marB="18288">
+                    <a:solidFill>
+                      <a:srgbClr val="16324F"/>
+                    </a:solidFill>
+                  </a:tcPr>
+                </a:tc>
+                <a:tc>
+                  <a:txBody>
+                    <a:bodyPr/>
+                    <a:lstStyle/>
+                    <a:p>
+                      <a:pPr algn="l">
+                        <a:spcAft>
+                          <a:spcPts val="0"/>
+                        </a:spcAft>
+                      </a:pPr>
+                      <a:r>
+                        <a:rPr sz="1400" b="1">
+                          <a:solidFill>
+                            <a:srgbClr val="FFFFFF"/>
+                          </a:solidFill>
+                          <a:latin typeface="Arial"/>
+                        </a:rPr>
+                        <a:t>Sparsity</a:t>
+                      </a:r>
+                    </a:p>
+                    <a:p>
+                      <a:pPr algn="l">
+                        <a:spcAft>
+                          <a:spcPts val="0"/>
+                        </a:spcAft>
+                      </a:pPr>
+                      <a:r>
+                        <a:rPr sz="1400" b="1">
+                          <a:solidFill>
+                            <a:srgbClr val="FFFFFF"/>
+                          </a:solidFill>
+                          <a:latin typeface="Arial"/>
+                        </a:rPr>
+                        <a:t>(higher better)</a:t>
+                      </a:r>
+                    </a:p>
+                  </a:txBody>
+                  <a:tcPr anchor="ctr" marL="41148" marR="41148" marT="18288" marB="18288">
+                    <a:solidFill>
+                      <a:srgbClr val="16324F"/>
+                    </a:solidFill>
+                  </a:tcPr>
+                </a:tc>
+              </a:tr>
+              <a:tr h="464820">
+                <a:tc>
+                  <a:txBody>
+                    <a:bodyPr/>
+                    <a:lstStyle/>
+                    <a:p>
+                      <a:pPr algn="l">
+                        <a:spcAft>
+                          <a:spcPts val="0"/>
+                        </a:spcAft>
+                      </a:pPr>
+                      <a:r>
+                        <a:rPr sz="1400" b="1">
+                          <a:solidFill>
+                            <a:srgbClr val="111111"/>
+                          </a:solidFill>
+                          <a:latin typeface="Arial"/>
+                        </a:rPr>
+                        <a:t>Native</a:t>
+                      </a:r>
+                    </a:p>
+                  </a:txBody>
+                  <a:tcPr anchor="ctr" marL="41148" marR="41148" marT="18288" marB="18288">
+                    <a:solidFill>
+                      <a:srgbClr val="D2EEF0"/>
+                    </a:solidFill>
+                  </a:tcPr>
+                </a:tc>
+                <a:tc>
+                  <a:txBody>
+                    <a:bodyPr/>
+                    <a:lstStyle/>
+                    <a:p>
+                      <a:pPr algn="l">
+                        <a:spcAft>
+                          <a:spcPts val="0"/>
+                        </a:spcAft>
+                      </a:pPr>
+                      <a:r>
+                        <a:rPr sz="1400" b="1">
+                          <a:solidFill>
+                            <a:srgbClr val="111111"/>
+                          </a:solidFill>
+                          <a:latin typeface="Arial"/>
+                        </a:rPr>
+                        <a:t>CEI 0.105 / ProtGNN N/A</a:t>
+                      </a:r>
+                    </a:p>
+                  </a:txBody>
+                  <a:tcPr anchor="ctr" marL="41148" marR="41148" marT="18288" marB="18288">
+                    <a:solidFill>
+                      <a:srgbClr val="D2EEF0"/>
+                    </a:solidFill>
+                  </a:tcPr>
+                </a:tc>
+                <a:tc>
+                  <a:txBody>
+                    <a:bodyPr/>
+                    <a:lstStyle/>
+                    <a:p>
+                      <a:pPr algn="l">
+                        <a:spcAft>
+                          <a:spcPts val="0"/>
+                        </a:spcAft>
+                      </a:pPr>
+                      <a:r>
+                        <a:rPr sz="1400" b="1">
+                          <a:solidFill>
+                            <a:srgbClr val="111111"/>
+                          </a:solidFill>
+                          <a:latin typeface="Arial"/>
+                        </a:rPr>
+                        <a:t>CEI 0.554 / ProtGNN N/A</a:t>
+                      </a:r>
+                    </a:p>
+                  </a:txBody>
+                  <a:tcPr anchor="ctr" marL="41148" marR="41148" marT="18288" marB="18288">
+                    <a:solidFill>
+                      <a:srgbClr val="D2EEF0"/>
+                    </a:solidFill>
+                  </a:tcPr>
+                </a:tc>
+                <a:tc>
+                  <a:txBody>
+                    <a:bodyPr/>
+                    <a:lstStyle/>
+                    <a:p>
+                      <a:pPr algn="l">
+                        <a:spcAft>
+                          <a:spcPts val="0"/>
+                        </a:spcAft>
+                      </a:pPr>
+                      <a:r>
+                        <a:rPr sz="1400" b="1">
+                          <a:solidFill>
+                            <a:srgbClr val="111111"/>
+                          </a:solidFill>
+                          <a:latin typeface="Arial"/>
+                        </a:rPr>
+                        <a:t>CEI 0.700 / ProtGNN N/A</a:t>
+                      </a:r>
+                    </a:p>
+                  </a:txBody>
+                  <a:tcPr anchor="ctr" marL="41148" marR="41148" marT="18288" marB="18288">
+                    <a:solidFill>
+                      <a:srgbClr val="D2EEF0"/>
+                    </a:solidFill>
+                  </a:tcPr>
+                </a:tc>
+              </a:tr>
+              <a:tr h="464820">
+                <a:tc>
+                  <a:txBody>
+                    <a:bodyPr/>
+                    <a:lstStyle/>
+                    <a:p>
+                      <a:pPr algn="l">
+                        <a:spcAft>
+                          <a:spcPts val="0"/>
+                        </a:spcAft>
+                      </a:pPr>
+                      <a:r>
+                        <a:rPr sz="1400" b="0">
+                          <a:solidFill>
+                            <a:srgbClr val="111111"/>
+                          </a:solidFill>
+                          <a:latin typeface="Arial"/>
+                        </a:rPr>
+                        <a:t>GradExplainer</a:t>
+                      </a:r>
+                    </a:p>
+                  </a:txBody>
+                  <a:tcPr anchor="ctr" marL="41148" marR="41148" marT="18288" marB="18288">
+                    <a:solidFill>
+                      <a:srgbClr val="F4F4F4"/>
+                    </a:solidFill>
+                  </a:tcPr>
+                </a:tc>
+                <a:tc>
+                  <a:txBody>
+                    <a:bodyPr/>
+                    <a:lstStyle/>
+                    <a:p>
+                      <a:pPr algn="l">
+                        <a:spcAft>
+                          <a:spcPts val="0"/>
+                        </a:spcAft>
+                      </a:pPr>
+                      <a:r>
+                        <a:rPr sz="1400" b="0">
+                          <a:solidFill>
+                            <a:srgbClr val="111111"/>
+                          </a:solidFill>
+                          <a:latin typeface="Arial"/>
+                        </a:rPr>
+                        <a:t>CEI 0.144 / ProtGNN 0.571</a:t>
+                      </a:r>
+                    </a:p>
+                  </a:txBody>
+                  <a:tcPr anchor="ctr" marL="41148" marR="41148" marT="18288" marB="18288">
+                    <a:solidFill>
+                      <a:srgbClr val="F4F4F4"/>
+                    </a:solidFill>
+                  </a:tcPr>
+                </a:tc>
+                <a:tc>
+                  <a:txBody>
+                    <a:bodyPr/>
+                    <a:lstStyle/>
+                    <a:p>
+                      <a:pPr algn="l">
+                        <a:spcAft>
+                          <a:spcPts val="0"/>
+                        </a:spcAft>
+                      </a:pPr>
+                      <a:r>
+                        <a:rPr sz="1400" b="0">
+                          <a:solidFill>
+                            <a:srgbClr val="111111"/>
+                          </a:solidFill>
+                          <a:latin typeface="Arial"/>
+                        </a:rPr>
+                        <a:t>CEI 0.509 / ProtGNN 0.510</a:t>
+                      </a:r>
+                    </a:p>
+                  </a:txBody>
+                  <a:tcPr anchor="ctr" marL="41148" marR="41148" marT="18288" marB="18288">
+                    <a:solidFill>
+                      <a:srgbClr val="F4F4F4"/>
+                    </a:solidFill>
+                  </a:tcPr>
+                </a:tc>
+                <a:tc>
+                  <a:txBody>
+                    <a:bodyPr/>
+                    <a:lstStyle/>
+                    <a:p>
+                      <a:pPr algn="l">
+                        <a:spcAft>
+                          <a:spcPts val="0"/>
+                        </a:spcAft>
+                      </a:pPr>
+                      <a:r>
+                        <a:rPr sz="1400" b="0">
+                          <a:solidFill>
+                            <a:srgbClr val="111111"/>
+                          </a:solidFill>
+                          <a:latin typeface="Arial"/>
+                        </a:rPr>
+                        <a:t>CEI 0.513 / ProtGNN 0.388</a:t>
+                      </a:r>
+                    </a:p>
+                  </a:txBody>
+                  <a:tcPr anchor="ctr" marL="41148" marR="41148" marT="18288" marB="18288">
+                    <a:solidFill>
+                      <a:srgbClr val="F4F4F4"/>
+                    </a:solidFill>
+                  </a:tcPr>
+                </a:tc>
+              </a:tr>
+              <a:tr h="464820">
+                <a:tc>
+                  <a:txBody>
+                    <a:bodyPr/>
+                    <a:lstStyle/>
+                    <a:p>
+                      <a:pPr algn="l">
+                        <a:spcAft>
+                          <a:spcPts val="0"/>
+                        </a:spcAft>
+                      </a:pPr>
+                      <a:r>
+                        <a:rPr sz="1400" b="0">
+                          <a:solidFill>
+                            <a:srgbClr val="111111"/>
+                          </a:solidFill>
+                          <a:latin typeface="Arial"/>
+                        </a:rPr>
+                        <a:t>Integrated Gradients</a:t>
+                      </a:r>
+                    </a:p>
+                  </a:txBody>
+                  <a:tcPr anchor="ctr" marL="41148" marR="41148" marT="18288" marB="18288">
+                    <a:solidFill>
+                      <a:srgbClr val="FFFFFF"/>
+                    </a:solidFill>
+                  </a:tcPr>
+                </a:tc>
+                <a:tc>
+                  <a:txBody>
+                    <a:bodyPr/>
+                    <a:lstStyle/>
+                    <a:p>
+                      <a:pPr algn="l">
+                        <a:spcAft>
+                          <a:spcPts val="0"/>
+                        </a:spcAft>
+                      </a:pPr>
+                      <a:r>
+                        <a:rPr sz="1400" b="0">
+                          <a:solidFill>
+                            <a:srgbClr val="111111"/>
+                          </a:solidFill>
+                          <a:latin typeface="Arial"/>
+                        </a:rPr>
+                        <a:t>CEI 0.100 / ProtGNN 0.570</a:t>
+                      </a:r>
+                    </a:p>
+                  </a:txBody>
+                  <a:tcPr anchor="ctr" marL="41148" marR="41148" marT="18288" marB="18288">
+                    <a:solidFill>
+                      <a:srgbClr val="FFFFFF"/>
+                    </a:solidFill>
+                  </a:tcPr>
+                </a:tc>
+                <a:tc>
+                  <a:txBody>
+                    <a:bodyPr/>
+                    <a:lstStyle/>
+                    <a:p>
+                      <a:pPr algn="l">
+                        <a:spcAft>
+                          <a:spcPts val="0"/>
+                        </a:spcAft>
+                      </a:pPr>
+                      <a:r>
+                        <a:rPr sz="1400" b="0">
+                          <a:solidFill>
+                            <a:srgbClr val="111111"/>
+                          </a:solidFill>
+                          <a:latin typeface="Arial"/>
+                        </a:rPr>
+                        <a:t>CEI 0.538 / ProtGNN 0.535</a:t>
+                      </a:r>
+                    </a:p>
+                  </a:txBody>
+                  <a:tcPr anchor="ctr" marL="41148" marR="41148" marT="18288" marB="18288">
+                    <a:solidFill>
+                      <a:srgbClr val="FFFFFF"/>
+                    </a:solidFill>
+                  </a:tcPr>
+                </a:tc>
+                <a:tc>
+                  <a:txBody>
+                    <a:bodyPr/>
+                    <a:lstStyle/>
+                    <a:p>
+                      <a:pPr algn="l">
+                        <a:spcAft>
+                          <a:spcPts val="0"/>
+                        </a:spcAft>
+                      </a:pPr>
+                      <a:r>
+                        <a:rPr sz="1400" b="0">
+                          <a:solidFill>
+                            <a:srgbClr val="111111"/>
+                          </a:solidFill>
+                          <a:latin typeface="Arial"/>
+                        </a:rPr>
+                        <a:t>CEI 0.521 / ProtGNN 0.289</a:t>
+                      </a:r>
+                    </a:p>
+                  </a:txBody>
+                  <a:tcPr anchor="ctr" marL="41148" marR="41148" marT="18288" marB="18288">
+                    <a:solidFill>
+                      <a:srgbClr val="FFFFFF"/>
+                    </a:solidFill>
+                  </a:tcPr>
+                </a:tc>
+              </a:tr>
+              <a:tr h="464820">
+                <a:tc>
+                  <a:txBody>
+                    <a:bodyPr/>
+                    <a:lstStyle/>
+                    <a:p>
+                      <a:pPr algn="l">
+                        <a:spcAft>
+                          <a:spcPts val="0"/>
+                        </a:spcAft>
+                      </a:pPr>
+                      <a:r>
+                        <a:rPr sz="1400" b="0">
+                          <a:solidFill>
+                            <a:srgbClr val="111111"/>
+                          </a:solidFill>
+                          <a:latin typeface="Arial"/>
+                        </a:rPr>
+                        <a:t>GNNExplainer</a:t>
+                      </a:r>
+                    </a:p>
+                  </a:txBody>
+                  <a:tcPr anchor="ctr" marL="41148" marR="41148" marT="18288" marB="18288">
+                    <a:solidFill>
+                      <a:srgbClr val="F4F4F4"/>
+                    </a:solidFill>
+                  </a:tcPr>
+                </a:tc>
+                <a:tc>
+                  <a:txBody>
+                    <a:bodyPr/>
+                    <a:lstStyle/>
+                    <a:p>
+                      <a:pPr algn="l">
+                        <a:spcAft>
+                          <a:spcPts val="0"/>
+                        </a:spcAft>
+                      </a:pPr>
+                      <a:r>
+                        <a:rPr sz="1400" b="0">
+                          <a:solidFill>
+                            <a:srgbClr val="111111"/>
+                          </a:solidFill>
+                          <a:latin typeface="Arial"/>
+                        </a:rPr>
+                        <a:t>CEI 0.398 / ProtGNN 0.576</a:t>
+                      </a:r>
+                    </a:p>
+                  </a:txBody>
+                  <a:tcPr anchor="ctr" marL="41148" marR="41148" marT="18288" marB="18288">
+                    <a:solidFill>
+                      <a:srgbClr val="F4F4F4"/>
+                    </a:solidFill>
+                  </a:tcPr>
+                </a:tc>
+                <a:tc>
+                  <a:txBody>
+                    <a:bodyPr/>
+                    <a:lstStyle/>
+                    <a:p>
+                      <a:pPr algn="l">
+                        <a:spcAft>
+                          <a:spcPts val="0"/>
+                        </a:spcAft>
+                      </a:pPr>
+                      <a:r>
+                        <a:rPr sz="1400" b="0">
+                          <a:solidFill>
+                            <a:srgbClr val="111111"/>
+                          </a:solidFill>
+                          <a:latin typeface="Arial"/>
+                        </a:rPr>
+                        <a:t>CEI 0.216 / ProtGNN 0.381</a:t>
+                      </a:r>
+                    </a:p>
+                  </a:txBody>
+                  <a:tcPr anchor="ctr" marL="41148" marR="41148" marT="18288" marB="18288">
+                    <a:solidFill>
+                      <a:srgbClr val="F4F4F4"/>
+                    </a:solidFill>
+                  </a:tcPr>
+                </a:tc>
+                <a:tc>
+                  <a:txBody>
+                    <a:bodyPr/>
+                    <a:lstStyle/>
+                    <a:p>
+                      <a:pPr algn="l">
+                        <a:spcAft>
+                          <a:spcPts val="0"/>
+                        </a:spcAft>
+                      </a:pPr>
+                      <a:r>
+                        <a:rPr sz="1400" b="0">
+                          <a:solidFill>
+                            <a:srgbClr val="111111"/>
+                          </a:solidFill>
+                          <a:latin typeface="Arial"/>
+                        </a:rPr>
+                        <a:t>CEI 0.269 / ProtGNN 0.270</a:t>
+                      </a:r>
+                    </a:p>
+                  </a:txBody>
+                  <a:tcPr anchor="ctr" marL="41148" marR="41148" marT="18288" marB="18288">
+                    <a:solidFill>
+                      <a:srgbClr val="F4F4F4"/>
+                    </a:solidFill>
+                  </a:tcPr>
+                </a:tc>
+              </a:tr>
+              <a:tr h="464820">
+                <a:tc>
+                  <a:txBody>
+                    <a:bodyPr/>
+                    <a:lstStyle/>
+                    <a:p>
+                      <a:pPr algn="l">
+                        <a:spcAft>
+                          <a:spcPts val="0"/>
+                        </a:spcAft>
+                      </a:pPr>
+                      <a:r>
+                        <a:rPr sz="1400" b="0">
+                          <a:solidFill>
+                            <a:srgbClr val="111111"/>
+                          </a:solidFill>
+                          <a:latin typeface="Arial"/>
+                        </a:rPr>
+                        <a:t>Random</a:t>
+                      </a:r>
+                    </a:p>
+                  </a:txBody>
+                  <a:tcPr anchor="ctr" marL="41148" marR="41148" marT="18288" marB="18288">
+                    <a:solidFill>
+                      <a:srgbClr val="FFFFFF"/>
+                    </a:solidFill>
+                  </a:tcPr>
+                </a:tc>
+                <a:tc>
+                  <a:txBody>
+                    <a:bodyPr/>
+                    <a:lstStyle/>
+                    <a:p>
+                      <a:pPr algn="l">
+                        <a:spcAft>
+                          <a:spcPts val="0"/>
+                        </a:spcAft>
+                      </a:pPr>
+                      <a:r>
+                        <a:rPr sz="1400" b="0">
+                          <a:solidFill>
+                            <a:srgbClr val="111111"/>
+                          </a:solidFill>
+                          <a:latin typeface="Arial"/>
+                        </a:rPr>
+                        <a:t>CEI 0.484 / ProtGNN 0.578</a:t>
+                      </a:r>
+                    </a:p>
+                  </a:txBody>
+                  <a:tcPr anchor="ctr" marL="41148" marR="41148" marT="18288" marB="18288">
+                    <a:solidFill>
+                      <a:srgbClr val="FFFFFF"/>
+                    </a:solidFill>
+                  </a:tcPr>
+                </a:tc>
+                <a:tc>
+                  <a:txBody>
+                    <a:bodyPr/>
+                    <a:lstStyle/>
+                    <a:p>
+                      <a:pPr algn="l">
+                        <a:spcAft>
+                          <a:spcPts val="0"/>
+                        </a:spcAft>
+                      </a:pPr>
+                      <a:r>
+                        <a:rPr sz="1400" b="0">
+                          <a:solidFill>
+                            <a:srgbClr val="111111"/>
+                          </a:solidFill>
+                          <a:latin typeface="Arial"/>
+                        </a:rPr>
+                        <a:t>CEI 0.107 / ProtGNN 0.309</a:t>
+                      </a:r>
+                    </a:p>
+                  </a:txBody>
+                  <a:tcPr anchor="ctr" marL="41148" marR="41148" marT="18288" marB="18288">
+                    <a:solidFill>
+                      <a:srgbClr val="FFFFFF"/>
+                    </a:solidFill>
+                  </a:tcPr>
+                </a:tc>
+                <a:tc>
+                  <a:txBody>
+                    <a:bodyPr/>
+                    <a:lstStyle/>
+                    <a:p>
+                      <a:pPr algn="l">
+                        <a:spcAft>
+                          <a:spcPts val="0"/>
+                        </a:spcAft>
+                      </a:pPr>
+                      <a:r>
+                        <a:rPr sz="1400" b="0">
+                          <a:solidFill>
+                            <a:srgbClr val="111111"/>
+                          </a:solidFill>
+                          <a:latin typeface="Arial"/>
+                        </a:rPr>
+                        <a:t>CEI 0.285 / ProtGNN 0.285</a:t>
+                      </a:r>
+                    </a:p>
+                  </a:txBody>
+                  <a:tcPr anchor="ctr" marL="41148" marR="41148" marT="18288" marB="18288">
+                    <a:solidFill>
+                      <a:srgbClr val="FFFFFF"/>
+                    </a:solidFill>
+                  </a:tcPr>
+                </a:tc>
+              </a:tr>
+            </a:tbl>
+          </a:graphicData>
+        </a:graphic>
+      </p:graphicFrame>
+      <p:sp>
+        <p:nvSpPr>
+          <p:cNvPr id="10" name="TextBox 9"/>
+          <p:cNvSpPr txBox="1"/>
+          <p:nvPr/>
+        </p:nvSpPr>
+        <p:spPr>
+          <a:xfrm>
+            <a:off x="4096512" y="4553712"/>
+            <a:ext cx="7452360" cy="457200"/>
+          </a:xfrm>
+          <a:prstGeom prst="rect">
+            <a:avLst/>
+          </a:prstGeom>
+          <a:noFill/>
+        </p:spPr>
+        <p:txBody>
+          <a:bodyPr wrap="square" anchor="t" lIns="36576" rIns="36576" tIns="18288" bIns="18288">
+            <a:spAutoFit/>
+          </a:bodyPr>
+          <a:lstStyle/>
+          <a:p>
+            <a:pPr algn="l"/>
+            <a:r>
+              <a:rPr sz="1400" b="0">
+                <a:solidFill>
+                  <a:srgbClr val="555555"/>
+                </a:solidFill>
+                <a:latin typeface="Arial"/>
+              </a:rPr>
+              <a:t>500 screen visits / 498 subjects / 3 seeds. Native ProtGNN attribution unavailable in this implementation.</a:t>
+            </a:r>
+          </a:p>
+        </p:txBody>
+      </p:sp>
+      <p:sp>
+        <p:nvSpPr>
+          <p:cNvPr id="11" name="TextBox 10"/>
+          <p:cNvSpPr txBox="1"/>
+          <p:nvPr/>
+        </p:nvSpPr>
+        <p:spPr>
+          <a:xfrm>
+            <a:off x="4096512" y="5010912"/>
+            <a:ext cx="7452360" cy="676656"/>
+          </a:xfrm>
+          <a:prstGeom prst="rect">
+            <a:avLst/>
+          </a:prstGeom>
+          <a:noFill/>
+        </p:spPr>
+        <p:txBody>
+          <a:bodyPr wrap="square" anchor="t" lIns="36576" rIns="36576" tIns="18288" bIns="18288">
+            <a:spAutoFit/>
+          </a:bodyPr>
+          <a:lstStyle/>
+          <a:p>
+            <a:pPr algn="l"/>
+            <a:r>
+              <a:rPr sz="1400" b="1">
+                <a:solidFill>
+                  <a:srgbClr val="111111"/>
+                </a:solidFill>
+                <a:latin typeface="Arial"/>
+              </a:rPr>
+              <a:t>Grad/IG: lower fidelity- and higher sparsity; fidelity+ gains not established. GNNExplainer fidelity+ favors ProtGNN.</a:t>
             </a:r>
           </a:p>
           <a:p>
@@ -7149,85 +7997,26 @@
               </a:spcBef>
             </a:pPr>
             <a:r>
-              <a:rPr sz="1800" b="1">
+              <a:rPr sz="1300" b="0">
                 <a:solidFill>
-                  <a:srgbClr val="111111"/>
+                  <a:srgbClr val="555555"/>
                 </a:solidFill>
                 <a:latin typeface="Arial"/>
               </a:rPr>
-              <a:t>Interpretable by construction. </a:t>
-            </a:r>
-            <a:r>
-              <a:rPr sz="1800" b="0">
-                <a:solidFill>
-                  <a:srgbClr val="111111"/>
-                </a:solidFill>
-                <a:latin typeface="Arial"/>
-              </a:rPr>
-              <a:t>Every CEI score splits exactly into signed evidence terms.</a:t>
-            </a:r>
-          </a:p>
-          <a:p>
-            <a:pPr algn="l">
-              <a:spcBef>
-                <a:spcPts val="600"/>
-              </a:spcBef>
-            </a:pPr>
-            <a:r>
-              <a:rPr sz="1800" b="1">
-                <a:solidFill>
-                  <a:srgbClr val="111111"/>
-                </a:solidFill>
-                <a:latin typeface="Arial"/>
-              </a:rPr>
-              <a:t>Explanation evidence is mixed. </a:t>
-            </a:r>
-            <a:r>
-              <a:rPr sz="1800" b="0">
-                <a:solidFill>
-                  <a:srgbClr val="111111"/>
-                </a:solidFill>
-                <a:latin typeface="Arial"/>
-              </a:rPr>
-              <a:t>Using Grad and IG on 500 screen visits, CEI outperforms ProtGNN on fidelity-minus and sparsity, not uniformly on fidelity-plus. Native ProtGNN attribution was unavailable in this implementation.</a:t>
-            </a:r>
-          </a:p>
-          <a:p>
-            <a:pPr algn="l">
-              <a:spcBef>
-                <a:spcPts val="600"/>
-              </a:spcBef>
-            </a:pPr>
-            <a:r>
-              <a:rPr sz="1800" b="1">
-                <a:solidFill>
-                  <a:srgbClr val="111111"/>
-                </a:solidFill>
-                <a:latin typeface="Arial"/>
-              </a:rPr>
-              <a:t>Superiority is not established. </a:t>
-            </a:r>
-            <a:r>
-              <a:rPr sz="1800" b="0">
-                <a:solidFill>
-                  <a:srgbClr val="111111"/>
-                </a:solidFill>
-                <a:latin typeface="Arial"/>
-              </a:rPr>
-              <a:t>The screen is inconclusive; this does not prove equivalence.</a:t>
-            </a:r>
-          </a:p>
-        </p:txBody>
-      </p:sp>
-      <p:sp>
-        <p:nvSpPr>
-          <p:cNvPr id="9" name="TextBox 8"/>
+              <a:t>Faithfulness to each model, not clinical validity.</a:t>
+            </a:r>
+          </a:p>
+        </p:txBody>
+      </p:sp>
+      <p:sp>
+        <p:nvSpPr>
+          <p:cNvPr id="12" name="TextBox 11"/>
           <p:cNvSpPr txBox="1"/>
           <p:nvPr/>
         </p:nvSpPr>
         <p:spPr>
           <a:xfrm>
-            <a:off x="548640" y="6172200"/>
+            <a:off x="548640" y="6126480"/>
             <a:ext cx="11064240" cy="411480"/>
           </a:xfrm>
           <a:prstGeom prst="rect">
@@ -7249,7 +8038,7 @@
                 </a:solidFill>
                 <a:latin typeface="Arial"/>
               </a:rPr>
-              <a:t>Max6 cohort, train-derived Top-10 classes; 10,000 train / 5,000 screen visits; seeds 1234, 2025, 7; patient-disjoint splits; rounded seed means. Held-out test never accessed.  Source: docs/cei-v3-evidence-2026-10-01.json</a:t>
+              <a:t>Fidelity-: remove important nodes; fidelity+: remove unimportant nodes and measure retention. Sparsity: excluded-node fraction at 90% importance mass.</a:t>
             </a:r>
           </a:p>
         </p:txBody>

</xml_diff>

<commit_message>
docs: correct CEI fidelity slide definitions
</commit_message>
<xml_diff>
--- a/docs/presentations/cei-overview/cei-overview.pptx
+++ b/docs/presentations/cei-overview/cei-overview.pptx
@@ -699,7 +699,7 @@
           </a:p>
           <a:p>
             <a:r>
-              <a:t>Fidelity-minus: prediction change after removing important nodes (keeping important nodes is thereby tested); fidelity-plus: prediction change when important nodes are retained after other nodes are removed. Sparsity is excluded-node fraction at 90% importance mass. Cohort: 500 screen visits / 498 subjects / 3 seeds. Native ProtGNN unavailable. These are model-faithfulness metrics, not clinical validity. No macro-F1 superiority or equivalence claim.</a:t>
+              <a:t>Fidelity-minus: probability drop when only important node inputs are kept (other node inputs are zeroed; edges are unchanged); fidelity-plus: drop when important node inputs are masked (zeroed; edges are unchanged). Sparsity is fraction excluded at 90% importance mass. Cohort: 500 screen visits / 498 subjects / 3 seeds. Native ProtGNN unavailable. These are model-faithfulness metrics, not clinical validity. No macro-F1 superiority or equivalence claim.</a:t>
             </a:r>
           </a:p>
         </p:txBody>
@@ -6715,7 +6715,7 @@
                 </a:solidFill>
                 <a:latin typeface="Arial"/>
               </a:rPr>
-              <a:t>Accuracy is close; explanation metrics differ</a:t>
+              <a:t>Prediction and explanation quality</a:t>
             </a:r>
           </a:p>
         </p:txBody>
@@ -6906,7 +6906,7 @@
                           </a:solidFill>
                           <a:latin typeface="Arial"/>
                         </a:rPr>
-                        <a:t>0.642</a:t>
+                        <a:t>0.6418</a:t>
                       </a:r>
                     </a:p>
                   </a:txBody>
@@ -6954,7 +6954,7 @@
                           </a:solidFill>
                           <a:latin typeface="Arial"/>
                         </a:rPr>
-                        <a:t>0.642</a:t>
+                        <a:t>0.6420</a:t>
                       </a:r>
                     </a:p>
                   </a:txBody>
@@ -7002,7 +7002,7 @@
                           </a:solidFill>
                           <a:latin typeface="Arial"/>
                         </a:rPr>
-                        <a:t>0.637</a:t>
+                        <a:t>0.6371</a:t>
                       </a:r>
                     </a:p>
                   </a:txBody>
@@ -7050,7 +7050,7 @@
                           </a:solidFill>
                           <a:latin typeface="Arial"/>
                         </a:rPr>
-                        <a:t>0.637</a:t>
+                        <a:t>0.6371</a:t>
                       </a:r>
                     </a:p>
                   </a:txBody>
@@ -7159,7 +7159,7 @@
         </p:nvSpPr>
         <p:spPr>
           <a:xfrm>
-            <a:off x="4069080" y="1261872"/>
+            <a:off x="4096512" y="1261872"/>
             <a:ext cx="7543800" cy="365760"/>
           </a:xfrm>
           <a:prstGeom prst="rect">
@@ -7181,7 +7181,7 @@
                 </a:solidFill>
                 <a:latin typeface="Arial"/>
               </a:rPr>
-              <a:t>Model-faithfulness metrics (absolute seed means)</a:t>
+              <a:t>Explanation quality: CEI / ProtGNN (3-seed means)</a:t>
             </a:r>
           </a:p>
         </p:txBody>
@@ -7222,7 +7222,7 @@
                         </a:spcAft>
                       </a:pPr>
                       <a:r>
-                        <a:rPr sz="1400" b="1">
+                        <a:rPr sz="1600" b="1">
                           <a:solidFill>
                             <a:srgbClr val="FFFFFF"/>
                           </a:solidFill>
@@ -7249,7 +7249,7 @@
                         </a:spcAft>
                       </a:pPr>
                       <a:r>
-                        <a:rPr sz="1400" b="1">
+                        <a:rPr sz="1600" b="1">
                           <a:solidFill>
                             <a:srgbClr val="FFFFFF"/>
                           </a:solidFill>
@@ -7265,7 +7265,7 @@
                         </a:spcAft>
                       </a:pPr>
                       <a:r>
-                        <a:rPr sz="1400" b="1">
+                        <a:rPr sz="1600" b="1">
                           <a:solidFill>
                             <a:srgbClr val="FFFFFF"/>
                           </a:solidFill>
@@ -7292,7 +7292,7 @@
                         </a:spcAft>
                       </a:pPr>
                       <a:r>
-                        <a:rPr sz="1400" b="1">
+                        <a:rPr sz="1600" b="1">
                           <a:solidFill>
                             <a:srgbClr val="FFFFFF"/>
                           </a:solidFill>
@@ -7308,7 +7308,7 @@
                         </a:spcAft>
                       </a:pPr>
                       <a:r>
-                        <a:rPr sz="1400" b="1">
+                        <a:rPr sz="1600" b="1">
                           <a:solidFill>
                             <a:srgbClr val="FFFFFF"/>
                           </a:solidFill>
@@ -7335,7 +7335,7 @@
                         </a:spcAft>
                       </a:pPr>
                       <a:r>
-                        <a:rPr sz="1400" b="1">
+                        <a:rPr sz="1600" b="1">
                           <a:solidFill>
                             <a:srgbClr val="FFFFFF"/>
                           </a:solidFill>
@@ -7351,7 +7351,7 @@
                         </a:spcAft>
                       </a:pPr>
                       <a:r>
-                        <a:rPr sz="1400" b="1">
+                        <a:rPr sz="1600" b="1">
                           <a:solidFill>
                             <a:srgbClr val="FFFFFF"/>
                           </a:solidFill>
@@ -7380,7 +7380,7 @@
                         </a:spcAft>
                       </a:pPr>
                       <a:r>
-                        <a:rPr sz="1400" b="1">
+                        <a:rPr sz="1600" b="1">
                           <a:solidFill>
                             <a:srgbClr val="111111"/>
                           </a:solidFill>
@@ -7407,13 +7407,13 @@
                         </a:spcAft>
                       </a:pPr>
                       <a:r>
-                        <a:rPr sz="1400" b="1">
+                        <a:rPr sz="1600" b="1">
                           <a:solidFill>
                             <a:srgbClr val="111111"/>
                           </a:solidFill>
                           <a:latin typeface="Arial"/>
                         </a:rPr>
-                        <a:t>CEI 0.105 / ProtGNN N/A</a:t>
+                        <a:t>0.105 / N/A</a:t>
                       </a:r>
                     </a:p>
                   </a:txBody>
@@ -7434,13 +7434,13 @@
                         </a:spcAft>
                       </a:pPr>
                       <a:r>
-                        <a:rPr sz="1400" b="1">
+                        <a:rPr sz="1600" b="1">
                           <a:solidFill>
                             <a:srgbClr val="111111"/>
                           </a:solidFill>
                           <a:latin typeface="Arial"/>
                         </a:rPr>
-                        <a:t>CEI 0.554 / ProtGNN N/A</a:t>
+                        <a:t>0.554 / N/A</a:t>
                       </a:r>
                     </a:p>
                   </a:txBody>
@@ -7461,13 +7461,13 @@
                         </a:spcAft>
                       </a:pPr>
                       <a:r>
-                        <a:rPr sz="1400" b="1">
+                        <a:rPr sz="1600" b="1">
                           <a:solidFill>
                             <a:srgbClr val="111111"/>
                           </a:solidFill>
                           <a:latin typeface="Arial"/>
                         </a:rPr>
-                        <a:t>CEI 0.700 / ProtGNN N/A</a:t>
+                        <a:t>0.700 / N/A</a:t>
                       </a:r>
                     </a:p>
                   </a:txBody>
@@ -7490,7 +7490,7 @@
                         </a:spcAft>
                       </a:pPr>
                       <a:r>
-                        <a:rPr sz="1400" b="0">
+                        <a:rPr sz="1600" b="0">
                           <a:solidFill>
                             <a:srgbClr val="111111"/>
                           </a:solidFill>
@@ -7517,13 +7517,13 @@
                         </a:spcAft>
                       </a:pPr>
                       <a:r>
-                        <a:rPr sz="1400" b="0">
+                        <a:rPr sz="1600" b="0">
                           <a:solidFill>
                             <a:srgbClr val="111111"/>
                           </a:solidFill>
                           <a:latin typeface="Arial"/>
                         </a:rPr>
-                        <a:t>CEI 0.144 / ProtGNN 0.571</a:t>
+                        <a:t>0.144 / 0.571</a:t>
                       </a:r>
                     </a:p>
                   </a:txBody>
@@ -7544,13 +7544,13 @@
                         </a:spcAft>
                       </a:pPr>
                       <a:r>
-                        <a:rPr sz="1400" b="0">
+                        <a:rPr sz="1600" b="0">
                           <a:solidFill>
                             <a:srgbClr val="111111"/>
                           </a:solidFill>
                           <a:latin typeface="Arial"/>
                         </a:rPr>
-                        <a:t>CEI 0.509 / ProtGNN 0.510</a:t>
+                        <a:t>0.509 / 0.510</a:t>
                       </a:r>
                     </a:p>
                   </a:txBody>
@@ -7571,13 +7571,13 @@
                         </a:spcAft>
                       </a:pPr>
                       <a:r>
-                        <a:rPr sz="1400" b="0">
+                        <a:rPr sz="1600" b="0">
                           <a:solidFill>
                             <a:srgbClr val="111111"/>
                           </a:solidFill>
                           <a:latin typeface="Arial"/>
                         </a:rPr>
-                        <a:t>CEI 0.513 / ProtGNN 0.388</a:t>
+                        <a:t>0.513 / 0.388</a:t>
                       </a:r>
                     </a:p>
                   </a:txBody>
@@ -7600,7 +7600,7 @@
                         </a:spcAft>
                       </a:pPr>
                       <a:r>
-                        <a:rPr sz="1400" b="0">
+                        <a:rPr sz="1600" b="0">
                           <a:solidFill>
                             <a:srgbClr val="111111"/>
                           </a:solidFill>
@@ -7627,13 +7627,13 @@
                         </a:spcAft>
                       </a:pPr>
                       <a:r>
-                        <a:rPr sz="1400" b="0">
+                        <a:rPr sz="1600" b="0">
                           <a:solidFill>
                             <a:srgbClr val="111111"/>
                           </a:solidFill>
                           <a:latin typeface="Arial"/>
                         </a:rPr>
-                        <a:t>CEI 0.100 / ProtGNN 0.570</a:t>
+                        <a:t>0.100 / 0.570</a:t>
                       </a:r>
                     </a:p>
                   </a:txBody>
@@ -7654,13 +7654,13 @@
                         </a:spcAft>
                       </a:pPr>
                       <a:r>
-                        <a:rPr sz="1400" b="0">
+                        <a:rPr sz="1600" b="0">
                           <a:solidFill>
                             <a:srgbClr val="111111"/>
                           </a:solidFill>
                           <a:latin typeface="Arial"/>
                         </a:rPr>
-                        <a:t>CEI 0.538 / ProtGNN 0.535</a:t>
+                        <a:t>0.538 / 0.535</a:t>
                       </a:r>
                     </a:p>
                   </a:txBody>
@@ -7681,13 +7681,13 @@
                         </a:spcAft>
                       </a:pPr>
                       <a:r>
-                        <a:rPr sz="1400" b="0">
+                        <a:rPr sz="1600" b="0">
                           <a:solidFill>
                             <a:srgbClr val="111111"/>
                           </a:solidFill>
                           <a:latin typeface="Arial"/>
                         </a:rPr>
-                        <a:t>CEI 0.521 / ProtGNN 0.289</a:t>
+                        <a:t>0.521 / 0.289</a:t>
                       </a:r>
                     </a:p>
                   </a:txBody>
@@ -7710,7 +7710,7 @@
                         </a:spcAft>
                       </a:pPr>
                       <a:r>
-                        <a:rPr sz="1400" b="0">
+                        <a:rPr sz="1600" b="0">
                           <a:solidFill>
                             <a:srgbClr val="111111"/>
                           </a:solidFill>
@@ -7737,13 +7737,13 @@
                         </a:spcAft>
                       </a:pPr>
                       <a:r>
-                        <a:rPr sz="1400" b="0">
+                        <a:rPr sz="1600" b="0">
                           <a:solidFill>
                             <a:srgbClr val="111111"/>
                           </a:solidFill>
                           <a:latin typeface="Arial"/>
                         </a:rPr>
-                        <a:t>CEI 0.398 / ProtGNN 0.576</a:t>
+                        <a:t>0.398 / 0.576</a:t>
                       </a:r>
                     </a:p>
                   </a:txBody>
@@ -7764,13 +7764,13 @@
                         </a:spcAft>
                       </a:pPr>
                       <a:r>
-                        <a:rPr sz="1400" b="0">
+                        <a:rPr sz="1600" b="0">
                           <a:solidFill>
                             <a:srgbClr val="111111"/>
                           </a:solidFill>
                           <a:latin typeface="Arial"/>
                         </a:rPr>
-                        <a:t>CEI 0.216 / ProtGNN 0.381</a:t>
+                        <a:t>0.216 / 0.381</a:t>
                       </a:r>
                     </a:p>
                   </a:txBody>
@@ -7791,13 +7791,13 @@
                         </a:spcAft>
                       </a:pPr>
                       <a:r>
-                        <a:rPr sz="1400" b="0">
+                        <a:rPr sz="1600" b="0">
                           <a:solidFill>
                             <a:srgbClr val="111111"/>
                           </a:solidFill>
                           <a:latin typeface="Arial"/>
                         </a:rPr>
-                        <a:t>CEI 0.269 / ProtGNN 0.270</a:t>
+                        <a:t>0.269 / 0.270</a:t>
                       </a:r>
                     </a:p>
                   </a:txBody>
@@ -7820,7 +7820,7 @@
                         </a:spcAft>
                       </a:pPr>
                       <a:r>
-                        <a:rPr sz="1400" b="0">
+                        <a:rPr sz="1600" b="0">
                           <a:solidFill>
                             <a:srgbClr val="111111"/>
                           </a:solidFill>
@@ -7847,13 +7847,13 @@
                         </a:spcAft>
                       </a:pPr>
                       <a:r>
-                        <a:rPr sz="1400" b="0">
+                        <a:rPr sz="1600" b="0">
                           <a:solidFill>
                             <a:srgbClr val="111111"/>
                           </a:solidFill>
                           <a:latin typeface="Arial"/>
                         </a:rPr>
-                        <a:t>CEI 0.484 / ProtGNN 0.578</a:t>
+                        <a:t>0.484 / 0.578</a:t>
                       </a:r>
                     </a:p>
                   </a:txBody>
@@ -7874,13 +7874,13 @@
                         </a:spcAft>
                       </a:pPr>
                       <a:r>
-                        <a:rPr sz="1400" b="0">
+                        <a:rPr sz="1600" b="0">
                           <a:solidFill>
                             <a:srgbClr val="111111"/>
                           </a:solidFill>
                           <a:latin typeface="Arial"/>
                         </a:rPr>
-                        <a:t>CEI 0.107 / ProtGNN 0.309</a:t>
+                        <a:t>0.107 / 0.309</a:t>
                       </a:r>
                     </a:p>
                   </a:txBody>
@@ -7901,13 +7901,13 @@
                         </a:spcAft>
                       </a:pPr>
                       <a:r>
-                        <a:rPr sz="1400" b="0">
+                        <a:rPr sz="1600" b="0">
                           <a:solidFill>
                             <a:srgbClr val="111111"/>
                           </a:solidFill>
                           <a:latin typeface="Arial"/>
                         </a:rPr>
-                        <a:t>CEI 0.285 / ProtGNN 0.285</a:t>
+                        <a:t>0.285 / 0.285</a:t>
                       </a:r>
                     </a:p>
                   </a:txBody>
@@ -8003,7 +8003,7 @@
                 </a:solidFill>
                 <a:latin typeface="Arial"/>
               </a:rPr>
-              <a:t>Faithfulness to each model, not clinical validity.</a:t>
+              <a:t>Faithfulness to each model, not clinical validity. Held-out test not used.</a:t>
             </a:r>
           </a:p>
         </p:txBody>
@@ -8038,7 +8038,7 @@
                 </a:solidFill>
                 <a:latin typeface="Arial"/>
               </a:rPr>
-              <a:t>Fidelity-: remove important nodes; fidelity+: remove unimportant nodes and measure retention. Sparsity: excluded-node fraction at 90% importance mass.</a:t>
+              <a:t>Fidelity-: probability drop when only important nodes are kept. Fidelity+: drop when important nodes are masked. Sparsity: fraction excluded at 90% importance mass.</a:t>
             </a:r>
           </a:p>
         </p:txBody>

</xml_diff>

<commit_message>
Add verified parameter counts to CEI overview deck
</commit_message>
<xml_diff>
--- a/docs/presentations/cei-overview/cei-overview.pptx
+++ b/docs/presentations/cei-overview/cei-overview.pptx
@@ -700,6 +700,12 @@
           <a:p>
             <a:r>
               <a:t>Fidelity-minus: probability drop when only important node inputs are kept (other node inputs are zeroed; edges are unchanged); fidelity-plus: drop when important node inputs are masked (zeroed; edges are unchanged). Sparsity is fraction excluded at 90% importance mass. Cohort: 500 screen visits / 498 subjects / 3 seeds. Native ProtGNN unavailable. These are model-faithfulness metrics, not clinical validity. No macro-F1 superiority or equivalence claim.</a:t>
+            </a:r>
+          </a:p>
+          <a:p/>
+          <a:p>
+            <a:r>
+              <a:t>Parameter counts (verified from the parent-run logical bindings; no checkpoint loading): CEI-GNN v3 C_K4 has 94,380 registered parameters, all active. CEI-GNN v2 additive control A is implemented in the v3 superset: 94,380 registered total, 92,300 active, 2,080 inactive. ProtGNN has 399,884 total, all active. These counts are identical across seeds 1234, 2025 and 7 and share preprocessing SHA-256 9a9ab7a4df8b9a9d6b6c56bc53335f94716df8041d2acd7428e7b512710c5ecd. Logical binding sources: core/C_K4_seed{seed}/binding.json, core/A_seed{seed}/binding.json, protgnn/P_seed{seed}/binding.json. Source roots: /Users/necatifurkancolak/AI-Workplace/Projects/current/MedGNN/.worktrees/run-cei3-core/comparison/standardized/clinical_runs_cei_v3_20260930 and /Users/necatifurkancolak/AI-Workplace/Projects/current/MedGNN/.worktrees/run-cei3-vs-protgnn/comparison/standardized/clinical_runs_cei_v3_vs_protgnn_20260930. XGBoost has no neural parameter count. Parameter counts do not establish compute speed.</a:t>
             </a:r>
           </a:p>
         </p:txBody>
@@ -6818,7 +6824,8 @@
                 <a:tableStyleId>{5C22544A-7EE6-4342-B048-85BDC9FD1C3A}</a:tableStyleId>
               </a:tblPr>
               <a:tblGrid>
-                <a:gridCol w="2240280"/>
+                <a:gridCol w="1417320"/>
+                <a:gridCol w="822960"/>
                 <a:gridCol w="1097280"/>
               </a:tblGrid>
               <a:tr h="411480">
@@ -6852,13 +6859,41 @@
                     <a:p>
                       <a:pPr algn="r"/>
                       <a:r>
-                        <a:rPr sz="1600" b="1">
+                        <a:rPr sz="1400" b="1">
                           <a:solidFill>
                             <a:srgbClr val="FFFFFF"/>
                           </a:solidFill>
                           <a:latin typeface="Arial"/>
                         </a:rPr>
                         <a:t>Macro-F1</a:t>
+                      </a:r>
+                    </a:p>
+                  </a:txBody>
+                  <a:tcPr anchor="ctr">
+                    <a:solidFill>
+                      <a:srgbClr val="16324F"/>
+                    </a:solidFill>
+                  </a:tcPr>
+                </a:tc>
+                <a:tc>
+                  <a:txBody>
+                    <a:bodyPr/>
+                    <a:lstStyle/>
+                    <a:p>
+                      <a:pPr algn="r"/>
+                      <a:r>
+                        <a:rPr sz="1500" b="1">
+                          <a:solidFill>
+                            <a:srgbClr val="FFFFFF"/>
+                          </a:solidFill>
+                          <a:latin typeface="Arial"/>
+                        </a:rPr>
+                        <a:t>Active</a:t>
+                      </a:r>
+                    </a:p>
+                    <a:p>
+                      <a:r>
+                        <a:t>params</a:t>
                       </a:r>
                     </a:p>
                   </a:txBody>
@@ -6900,13 +6935,36 @@
                     <a:p>
                       <a:pPr algn="r"/>
                       <a:r>
-                        <a:rPr sz="1600" b="1">
+                        <a:rPr sz="1400" b="1">
                           <a:solidFill>
                             <a:srgbClr val="111111"/>
                           </a:solidFill>
                           <a:latin typeface="Arial"/>
                         </a:rPr>
                         <a:t>0.6418</a:t>
+                      </a:r>
+                    </a:p>
+                  </a:txBody>
+                  <a:tcPr anchor="ctr">
+                    <a:solidFill>
+                      <a:srgbClr val="D2EEF0"/>
+                    </a:solidFill>
+                  </a:tcPr>
+                </a:tc>
+                <a:tc>
+                  <a:txBody>
+                    <a:bodyPr/>
+                    <a:lstStyle/>
+                    <a:p>
+                      <a:pPr algn="r"/>
+                      <a:r>
+                        <a:rPr sz="1500" b="1">
+                          <a:solidFill>
+                            <a:srgbClr val="111111"/>
+                          </a:solidFill>
+                          <a:latin typeface="Arial"/>
+                        </a:rPr>
+                        <a:t>94,380</a:t>
                       </a:r>
                     </a:p>
                   </a:txBody>
@@ -6948,13 +7006,36 @@
                     <a:p>
                       <a:pPr algn="r"/>
                       <a:r>
-                        <a:rPr sz="1600" b="0">
+                        <a:rPr sz="1400" b="0">
                           <a:solidFill>
                             <a:srgbClr val="111111"/>
                           </a:solidFill>
                           <a:latin typeface="Arial"/>
                         </a:rPr>
                         <a:t>0.6420</a:t>
+                      </a:r>
+                    </a:p>
+                  </a:txBody>
+                  <a:tcPr anchor="ctr">
+                    <a:solidFill>
+                      <a:srgbClr val="F4F4F4"/>
+                    </a:solidFill>
+                  </a:tcPr>
+                </a:tc>
+                <a:tc>
+                  <a:txBody>
+                    <a:bodyPr/>
+                    <a:lstStyle/>
+                    <a:p>
+                      <a:pPr algn="r"/>
+                      <a:r>
+                        <a:rPr sz="1500" b="0">
+                          <a:solidFill>
+                            <a:srgbClr val="111111"/>
+                          </a:solidFill>
+                          <a:latin typeface="Arial"/>
+                        </a:rPr>
+                        <a:t>92,300</a:t>
                       </a:r>
                     </a:p>
                   </a:txBody>
@@ -6996,13 +7077,36 @@
                     <a:p>
                       <a:pPr algn="r"/>
                       <a:r>
-                        <a:rPr sz="1600" b="0">
+                        <a:rPr sz="1400" b="0">
                           <a:solidFill>
                             <a:srgbClr val="111111"/>
                           </a:solidFill>
                           <a:latin typeface="Arial"/>
                         </a:rPr>
                         <a:t>0.6371</a:t>
+                      </a:r>
+                    </a:p>
+                  </a:txBody>
+                  <a:tcPr anchor="ctr">
+                    <a:solidFill>
+                      <a:srgbClr val="FFFFFF"/>
+                    </a:solidFill>
+                  </a:tcPr>
+                </a:tc>
+                <a:tc>
+                  <a:txBody>
+                    <a:bodyPr/>
+                    <a:lstStyle/>
+                    <a:p>
+                      <a:pPr algn="r"/>
+                      <a:r>
+                        <a:rPr sz="1500" b="0">
+                          <a:solidFill>
+                            <a:srgbClr val="111111"/>
+                          </a:solidFill>
+                          <a:latin typeface="Arial"/>
+                        </a:rPr>
+                        <a:t>399,884</a:t>
                       </a:r>
                     </a:p>
                   </a:txBody>
@@ -7044,7 +7148,7 @@
                     <a:p>
                       <a:pPr algn="r"/>
                       <a:r>
-                        <a:rPr sz="1600" b="0">
+                        <a:rPr sz="1400" b="0">
                           <a:solidFill>
                             <a:srgbClr val="111111"/>
                           </a:solidFill>
@@ -7060,6 +7164,29 @@
                     </a:solidFill>
                   </a:tcPr>
                 </a:tc>
+                <a:tc>
+                  <a:txBody>
+                    <a:bodyPr/>
+                    <a:lstStyle/>
+                    <a:p>
+                      <a:pPr algn="r"/>
+                      <a:r>
+                        <a:rPr sz="1500" b="0">
+                          <a:solidFill>
+                            <a:srgbClr val="111111"/>
+                          </a:solidFill>
+                          <a:latin typeface="Arial"/>
+                        </a:rPr>
+                        <a:t>N/A</a:t>
+                      </a:r>
+                    </a:p>
+                  </a:txBody>
+                  <a:tcPr anchor="ctr">
+                    <a:solidFill>
+                      <a:srgbClr val="F4F4F4"/>
+                    </a:solidFill>
+                  </a:tcPr>
+                </a:tc>
               </a:tr>
             </a:tbl>
           </a:graphicData>
@@ -7108,7 +7235,42 @@
         </p:nvSpPr>
         <p:spPr>
           <a:xfrm>
-            <a:off x="566928" y="4572000"/>
+            <a:off x="566928" y="4352544"/>
+            <a:ext cx="3337560" cy="640080"/>
+          </a:xfrm>
+          <a:prstGeom prst="rect">
+            <a:avLst/>
+          </a:prstGeom>
+          <a:noFill/>
+        </p:spPr>
+        <p:txBody>
+          <a:bodyPr wrap="square" anchor="t" lIns="36576" rIns="36576" tIns="18288" bIns="18288">
+            <a:spAutoFit/>
+          </a:bodyPr>
+          <a:lstStyle/>
+          <a:p>
+            <a:pPr algn="l"/>
+            <a:r>
+              <a:rPr sz="1200" b="0">
+                <a:solidFill>
+                  <a:srgbClr val="555555"/>
+                </a:solidFill>
+                <a:latin typeface="Arial"/>
+              </a:rPr>
+              <a:t>v2 control: 94,380 total, 92,300 active. XGBoost: not a neural parameter count.</a:t>
+            </a:r>
+          </a:p>
+        </p:txBody>
+      </p:sp>
+      <p:sp>
+        <p:nvSpPr>
+          <p:cNvPr id="8" name="TextBox 7"/>
+          <p:cNvSpPr txBox="1"/>
+          <p:nvPr/>
+        </p:nvSpPr>
+        <p:spPr>
+          <a:xfrm>
+            <a:off x="566928" y="5010912"/>
             <a:ext cx="3291840" cy="1005840"/>
           </a:xfrm>
           <a:prstGeom prst="rect">
@@ -7133,27 +7295,11 @@
               <a:t>No decisive accuracy gain on the primary screen.</a:t>
             </a:r>
           </a:p>
-          <a:p>
-            <a:pPr algn="l">
-              <a:spcBef>
-                <a:spcPts val="600"/>
-              </a:spcBef>
-            </a:pPr>
-            <a:r>
-              <a:rPr sz="1400" b="0">
-                <a:solidFill>
-                  <a:srgbClr val="111111"/>
-                </a:solidFill>
-                <a:latin typeface="Arial"/>
-              </a:rPr>
-              <a:t>No superiority or equivalence claim.</a:t>
-            </a:r>
-          </a:p>
-        </p:txBody>
-      </p:sp>
-      <p:sp>
-        <p:nvSpPr>
-          <p:cNvPr id="8" name="TextBox 7"/>
+        </p:txBody>
+      </p:sp>
+      <p:sp>
+        <p:nvSpPr>
+          <p:cNvPr id="9" name="TextBox 8"/>
           <p:cNvSpPr txBox="1"/>
           <p:nvPr/>
         </p:nvSpPr>
@@ -7188,7 +7334,7 @@
       </p:sp>
       <p:graphicFrame>
         <p:nvGraphicFramePr>
-          <p:cNvPr id="9" name="Table 8"/>
+          <p:cNvPr id="10" name="Table 9"/>
           <p:cNvGraphicFramePr>
             <a:graphicFrameLocks noGrp="1"/>
           </p:cNvGraphicFramePr>
@@ -7924,7 +8070,7 @@
       </p:graphicFrame>
       <p:sp>
         <p:nvSpPr>
-          <p:cNvPr id="10" name="TextBox 9"/>
+          <p:cNvPr id="11" name="TextBox 10"/>
           <p:cNvSpPr txBox="1"/>
           <p:nvPr/>
         </p:nvSpPr>
@@ -7959,7 +8105,7 @@
       </p:sp>
       <p:sp>
         <p:nvSpPr>
-          <p:cNvPr id="11" name="TextBox 10"/>
+          <p:cNvPr id="12" name="TextBox 11"/>
           <p:cNvSpPr txBox="1"/>
           <p:nvPr/>
         </p:nvSpPr>
@@ -8010,7 +8156,7 @@
       </p:sp>
       <p:sp>
         <p:nvSpPr>
-          <p:cNvPr id="12" name="TextBox 11"/>
+          <p:cNvPr id="13" name="TextBox 12"/>
           <p:cNvSpPr txBox="1"/>
           <p:nvPr/>
         </p:nvSpPr>

</xml_diff>

<commit_message>
Sync final CEI overview presentation artifacts
</commit_message>
<xml_diff>
--- a/docs/presentations/cei-overview/cei-overview.pptx
+++ b/docs/presentations/cei-overview/cei-overview.pptx
@@ -7200,7 +7200,7 @@
         </p:nvSpPr>
         <p:spPr>
           <a:xfrm>
-            <a:off x="566928" y="3822191"/>
+            <a:off x="566928" y="4005072"/>
             <a:ext cx="3337560" cy="603504"/>
           </a:xfrm>
           <a:prstGeom prst="rect">
@@ -7235,7 +7235,7 @@
         </p:nvSpPr>
         <p:spPr>
           <a:xfrm>
-            <a:off x="566928" y="4352544"/>
+            <a:off x="566928" y="4535424"/>
             <a:ext cx="3337560" cy="640080"/>
           </a:xfrm>
           <a:prstGeom prst="rect">
@@ -7270,7 +7270,7 @@
         </p:nvSpPr>
         <p:spPr>
           <a:xfrm>
-            <a:off x="566928" y="5010912"/>
+            <a:off x="566928" y="5193792"/>
             <a:ext cx="3291840" cy="1005840"/>
           </a:xfrm>
           <a:prstGeom prst="rect">

</xml_diff>